<commit_message>
Give Week 4 its own reporting videos
Replaces the reused videos in Week 4 (Reliable SQL Reports) with three new
ones made for it: counting at the right grain, conditional counts with
FILTER, and one latest event per ticket with ROW_NUMBER.

Co-Authored-By: Claude Opus 5.5 <noreply@anthropic.com>
</commit_message>
<xml_diff>
--- a/week_04/week_04_reliable_sql_reports.pptx
+++ b/week_04/week_04_reliable_sql_reports.pptx
@@ -2045,7 +2045,7 @@
           <a:lstStyle/>
           <a:p>
             <a:r>
-              <a:t>These short animations go with this week's reading. Students can watch them before class to preview the mechanisms, or afterwards to review: What does one row mean after a join? (1:16); Counting workload, including zero (1:28); A view stores a query, not rows (1:14). Each video is silent with on-screen captions and a subtitle file, and is linked from the Week 4 README. The diagrams are schematic illustrations, not benchmarks.</a:t>
+              <a:t>These short animations go with this week's reading. Students can watch them before class to preview the mechanisms, or afterwards to review: Count requests, not ticket-event pairs (1:30); Conditional counts without losing tickets (1:19); One latest event per ticket (1:41). Each video is silent with on-screen captions and a subtitle file, and is linked from the Week 4 README. The diagrams are schematic illustrations, not benchmarks.</a:t>
             </a:r>
           </a:p>
         </p:txBody>
@@ -11808,7 +11808,7 @@
       </p:sp>
       <p:pic>
         <p:nvPicPr>
-          <p:cNvPr id="7" name="video-thumb-1" descr="02_join_grain.png">
+          <p:cNvPr id="7" name="video-thumb-1" descr="04_count_at_grain.png">
             <a:hlinkClick r:id="rId3"/>
           </p:cNvPr>
           <p:cNvPicPr>
@@ -11868,14 +11868,14 @@
                 <a:latin typeface="Helvetica Neue"/>
                 <a:hlinkClick r:id="rId3"/>
               </a:rPr>
-              <a:t>▶ What does one row mean after a join?  (1:16)</a:t>
+              <a:t>▶ Count requests, not ticket-event pairs  (1:30)</a:t>
             </a:r>
           </a:p>
         </p:txBody>
       </p:sp>
       <p:pic>
         <p:nvPicPr>
-          <p:cNvPr id="9" name="video-thumb-2" descr="03_zero_counts.png">
+          <p:cNvPr id="9" name="video-thumb-2" descr="05_conditional_counts.png">
             <a:hlinkClick r:id="rId5"/>
           </p:cNvPr>
           <p:cNvPicPr>
@@ -11935,14 +11935,14 @@
                 <a:latin typeface="Helvetica Neue"/>
                 <a:hlinkClick r:id="rId5"/>
               </a:rPr>
-              <a:t>▶ Counting workload, including zero  (1:28)</a:t>
+              <a:t>▶ Conditional counts without losing tickets  (1:19)</a:t>
             </a:r>
           </a:p>
         </p:txBody>
       </p:sp>
       <p:pic>
         <p:nvPicPr>
-          <p:cNvPr id="11" name="video-thumb-3" descr="01_view_stored_query.png">
+          <p:cNvPr id="11" name="video-thumb-3" descr="06_latest_event.png">
             <a:hlinkClick r:id="rId7"/>
           </p:cNvPr>
           <p:cNvPicPr>
@@ -12002,7 +12002,7 @@
                 <a:latin typeface="Helvetica Neue"/>
                 <a:hlinkClick r:id="rId7"/>
               </a:rPr>
-              <a:t>▶ A view stores a query, not rows  (1:14)</a:t>
+              <a:t>▶ One latest event per ticket  (1:41)</a:t>
             </a:r>
           </a:p>
         </p:txBody>

</xml_diff>